<commit_message>
HIRA SY ANDININY FINAL
</commit_message>
<xml_diff>
--- a/fafana_2025-07-23.pptx
+++ b/fafana_2025-07-23.pptx
@@ -3181,7 +3181,7 @@
                 </a:solidFill>
                 <a:latin typeface="Verdana"/>
               </a:rPr>
-              <a:t>1. </a:t>
+              <a:t>1- </a:t>
             </a:r>
             <a:r>
               <a:rPr lang="en-US" sz="4500" b="true">
@@ -3355,23 +3355,20 @@
             <a:r>
               <a:rPr lang="en-US" sz="4500" b="true">
                 <a:solidFill>
-                  <a:srgbClr val="FFFFFF"/>
-                </a:solidFill>
-                <a:latin typeface="Verdana"/>
-              </a:rPr>
-              <a:t>Fiverenana</a:t>
-            </a:r>
-          </a:p>
-          <a:p>
-            <a:pPr algn="ctr"/>
-            <a:r>
-              <a:rPr lang="en-US" sz="4500" b="true">
-                <a:solidFill>
-                  <a:srgbClr val="FFFFFF"/>
-                </a:solidFill>
-                <a:latin typeface="Verdana"/>
-              </a:rPr>
-              <a:t>Na onena ny fonao</a:t>
+                  <a:srgbClr val="FFCC00"/>
+                </a:solidFill>
+                <a:latin typeface="Verdana"/>
+              </a:rPr>
+              <a:t>Fiv:</a:t>
+            </a:r>
+            <a:r>
+              <a:rPr lang="en-US" sz="4500" b="true">
+                <a:solidFill>
+                  <a:srgbClr val="FFFFFF"/>
+                </a:solidFill>
+                <a:latin typeface="Verdana"/>
+              </a:rPr>
+              <a:t> Na onena ny fonao</a:t>
             </a:r>
           </a:p>
           <a:p>
@@ -3540,7 +3537,7 @@
                 </a:solidFill>
                 <a:latin typeface="Verdana"/>
               </a:rPr>
-              <a:t>2. </a:t>
+              <a:t>2- </a:t>
             </a:r>
             <a:r>
               <a:rPr lang="en-US" sz="4500" b="true">
@@ -3718,7 +3715,7 @@
                 </a:solidFill>
                 <a:latin typeface="Verdana"/>
               </a:rPr>
-              <a:t> :,: Inty tamy aho, </a:t>
+              <a:t>:,: Inty tamy aho,</a:t>
             </a:r>
           </a:p>
           <a:p>
@@ -3875,7 +3872,7 @@
                 </a:solidFill>
                 <a:latin typeface="Verdana"/>
               </a:rPr>
-              <a:t>1. </a:t>
+              <a:t>1- </a:t>
             </a:r>
             <a:r>
               <a:rPr lang="en-US" sz="4500" b="true">
@@ -4222,7 +4219,7 @@
                 </a:solidFill>
                 <a:latin typeface="Verdana"/>
               </a:rPr>
-              <a:t>2. </a:t>
+              <a:t>2- </a:t>
             </a:r>
             <a:r>
               <a:rPr lang="en-US" sz="4500" b="true">
@@ -4569,7 +4566,7 @@
                 </a:solidFill>
                 <a:latin typeface="Verdana"/>
               </a:rPr>
-              <a:t>3. </a:t>
+              <a:t>3- </a:t>
             </a:r>
             <a:r>
               <a:rPr lang="en-US" sz="4500" b="true">
@@ -4590,19 +4587,19 @@
                 </a:solidFill>
                 <a:latin typeface="Verdana"/>
               </a:rPr>
-              <a:t>Fara-fanasana anao; </a:t>
-            </a:r>
-          </a:p>
-          <a:p>
-            <a:pPr algn="ctr"/>
-            <a:r>
-              <a:rPr lang="en-US" sz="4500" b="true">
-                <a:solidFill>
-                  <a:srgbClr val="FFFFFF"/>
-                </a:solidFill>
-                <a:latin typeface="Verdana"/>
-              </a:rPr>
-              <a:t>Sao anio no fotoana </a:t>
+              <a:t>Fara-fanasana anao;</a:t>
+            </a:r>
+          </a:p>
+          <a:p>
+            <a:pPr algn="ctr"/>
+            <a:r>
+              <a:rPr lang="en-US" sz="4500" b="true">
+                <a:solidFill>
+                  <a:srgbClr val="FFFFFF"/>
+                </a:solidFill>
+                <a:latin typeface="Verdana"/>
+              </a:rPr>
+              <a:t>Sao anio no fotoana</a:t>
             </a:r>
           </a:p>
           <a:p>
@@ -4747,31 +4744,31 @@
                 </a:solidFill>
                 <a:latin typeface="Verdana"/>
               </a:rPr>
-              <a:t>Ka aza mba misalasala, </a:t>
-            </a:r>
-          </a:p>
-          <a:p>
-            <a:pPr algn="ctr"/>
-            <a:r>
-              <a:rPr lang="en-US" sz="4500" b="true">
-                <a:solidFill>
-                  <a:srgbClr val="FFFFFF"/>
-                </a:solidFill>
-                <a:latin typeface="Verdana"/>
-              </a:rPr>
-              <a:t>Sao manjary neninao, </a:t>
-            </a:r>
-          </a:p>
-          <a:p>
-            <a:pPr algn="ctr"/>
-            <a:r>
-              <a:rPr lang="en-US" sz="4500" b="true">
-                <a:solidFill>
-                  <a:srgbClr val="FFFFFF"/>
-                </a:solidFill>
-                <a:latin typeface="Verdana"/>
-              </a:rPr>
-              <a:t>Raha tsy mety mahalala </a:t>
+              <a:t>Ka aza mba misalasala,</a:t>
+            </a:r>
+          </a:p>
+          <a:p>
+            <a:pPr algn="ctr"/>
+            <a:r>
+              <a:rPr lang="en-US" sz="4500" b="true">
+                <a:solidFill>
+                  <a:srgbClr val="FFFFFF"/>
+                </a:solidFill>
+                <a:latin typeface="Verdana"/>
+              </a:rPr>
+              <a:t>Sao manjary neninao,</a:t>
+            </a:r>
+          </a:p>
+          <a:p>
+            <a:pPr algn="ctr"/>
+            <a:r>
+              <a:rPr lang="en-US" sz="4500" b="true">
+                <a:solidFill>
+                  <a:srgbClr val="FFFFFF"/>
+                </a:solidFill>
+                <a:latin typeface="Verdana"/>
+              </a:rPr>
+              <a:t>Raha tsy mety mahalala</a:t>
             </a:r>
           </a:p>
           <a:p>
@@ -4916,7 +4913,7 @@
                 </a:solidFill>
                 <a:latin typeface="Verdana"/>
               </a:rPr>
-              <a:t>4. </a:t>
+              <a:t>4- </a:t>
             </a:r>
             <a:r>
               <a:rPr lang="en-US" sz="4500" b="true">
@@ -4949,7 +4946,7 @@
                 </a:solidFill>
                 <a:latin typeface="Verdana"/>
               </a:rPr>
-              <a:t>Fa henika ny hasoavanao </a:t>
+              <a:t>Fa henika ny hasoavanao</a:t>
             </a:r>
           </a:p>
           <a:p>
@@ -5275,19 +5272,19 @@
                 </a:solidFill>
                 <a:latin typeface="Verdana"/>
               </a:rPr>
-              <a:t>Soa lehibe no nentinao taty, </a:t>
-            </a:r>
-          </a:p>
-          <a:p>
-            <a:pPr algn="ctr"/>
-            <a:r>
-              <a:rPr lang="en-US" sz="4500" b="true">
-                <a:solidFill>
-                  <a:srgbClr val="FFFFFF"/>
-                </a:solidFill>
-                <a:latin typeface="Verdana"/>
-              </a:rPr>
-              <a:t>Avy izahay, mba hisaotra Anao </a:t>
+              <a:t>Soa lehibe no nentinao taty,</a:t>
+            </a:r>
+          </a:p>
+          <a:p>
+            <a:pPr algn="ctr"/>
+            <a:r>
+              <a:rPr lang="en-US" sz="4500" b="true">
+                <a:solidFill>
+                  <a:srgbClr val="FFFFFF"/>
+                </a:solidFill>
+                <a:latin typeface="Verdana"/>
+              </a:rPr>
+              <a:t>Avy izahay, mba hisaotra Anao</a:t>
             </a:r>
           </a:p>
           <a:p>
@@ -5625,7 +5622,7 @@
                 </a:solidFill>
                 <a:latin typeface="Verdana"/>
               </a:rPr>
-              <a:t>Ny fiderana 'zay entinay, </a:t>
+              <a:t>Ny fiderana 'zay entinay,</a:t>
             </a:r>
           </a:p>
           <a:p>
@@ -5782,7 +5779,7 @@
                 </a:solidFill>
                 <a:latin typeface="Verdana"/>
               </a:rPr>
-              <a:t>3. </a:t>
+              <a:t>3- </a:t>
             </a:r>
             <a:r>
               <a:rPr lang="en-US" sz="4500" b="true">
@@ -6322,7 +6319,7 @@
                 </a:solidFill>
                 <a:latin typeface="Verdana"/>
               </a:rPr>
-              <a:t>Ny fiderana 'zay entinay, </a:t>
+              <a:t>Ny fiderana 'zay entinay,</a:t>
             </a:r>
           </a:p>
           <a:p>
@@ -6479,7 +6476,7 @@
                 </a:solidFill>
                 <a:latin typeface="Verdana"/>
               </a:rPr>
-              <a:t>1. </a:t>
+              <a:t>1- </a:t>
             </a:r>
             <a:r>
               <a:rPr lang="en-US" sz="4500" b="true">
@@ -6524,7 +6521,7 @@
                 </a:solidFill>
                 <a:latin typeface="Verdana"/>
               </a:rPr>
-              <a:t>Tsy azo atao </a:t>
+              <a:t>Tsy azo atao</a:t>
             </a:r>
           </a:p>
           <a:p>
@@ -6585,18 +6582,6 @@
                 <a:latin typeface="Verdana"/>
               </a:rPr>
               <a:t>Herim-po, herin-tsaina koa</a:t>
-            </a:r>
-          </a:p>
-          <a:p>
-            <a:pPr algn="ctr"/>
-            <a:r>
-              <a:rPr lang="en-US" sz="4500" b="true">
-                <a:solidFill>
-                  <a:srgbClr val="FFFFFF"/>
-                </a:solidFill>
-                <a:latin typeface="Verdana"/>
-              </a:rPr>
-              <a:t>F.F 16</a:t>
             </a:r>
           </a:p>
         </p:txBody>

</xml_diff>